<commit_message>
docs: añade sección de librerías externas y menciona volúmenes RAR nativos
Explica dependencia por dependencia qué resuelve cada librería del sistema (y
qué no) y por qué el contenedor de ZIP/tar es 100% propio. Suma «Volúmenes RAR
nativos» al recorrido de funcionalidades. Reindexa las secciones 7→15.
</commit_message>
<xml_diff>
--- a/docs/FilePackr-presentacion.pptx
+++ b/docs/FilePackr-presentacion.pptx
@@ -11,6 +11,7 @@
     <p:sldId id="259" r:id="rId10"/>
     <p:sldId id="260" r:id="rId11"/>
     <p:sldId id="261" r:id="rId12"/>
+    <p:sldId id="270" r:id="rId21"/>
     <p:sldId id="262" r:id="rId13"/>
     <p:sldId id="263" r:id="rId14"/>
     <p:sldId id="264" r:id="rId15"/>
@@ -3450,7 +3451,7 @@
                 </a:solidFill>
                 <a:latin typeface="Cambria"/>
               </a:rPr>
-              <a:t>Calidad y seguridad</a:t>
+              <a:t>Decisión: cifrado interoperable</a:t>
             </a:r>
           </a:p>
         </p:txBody>
@@ -3463,47 +3464,7 @@
         </p:nvSpPr>
         <p:spPr>
           <a:xfrm>
-            <a:off x="1024128" y="1874519"/>
-            <a:ext cx="10058400" cy="457200"/>
-          </a:xfrm>
-          <a:prstGeom prst="rect">
-            <a:avLst/>
-          </a:prstGeom>
-          <a:noFill/>
-        </p:spPr>
-        <p:txBody>
-          <a:bodyPr wrap="square" anchor="t" lIns="0" rIns="0" tIns="0" bIns="0">
-            <a:spAutoFit/>
-          </a:bodyPr>
-          <a:lstStyle/>
-          <a:p>
-            <a:pPr algn="l">
-              <a:spcAft>
-                <a:spcPts val="600"/>
-              </a:spcAft>
-              <a:buNone/>
-            </a:pPr>
-            <a:r>
-              <a:rPr sz="1300" b="1" i="0">
-                <a:solidFill>
-                  <a:srgbClr val="028090"/>
-                </a:solidFill>
-                <a:latin typeface="Calibri"/>
-              </a:rPr>
-              <a:t>CALIDAD</a:t>
-            </a:r>
-          </a:p>
-        </p:txBody>
-      </p:sp>
-      <p:sp>
-        <p:nvSpPr>
-          <p:cNvPr id="6" name="TextBox 5"/>
-          <p:cNvSpPr txBox="1"/>
-          <p:nvPr/>
-        </p:nvSpPr>
-        <p:spPr>
-          <a:xfrm>
-            <a:off x="1024128" y="2286000"/>
+            <a:off x="1024128" y="1920240"/>
             <a:ext cx="10058400" cy="4206240"/>
           </a:xfrm>
           <a:prstGeom prst="rect">
@@ -3522,7 +3483,7 @@
                 <a:spcPct val="110000"/>
               </a:lnSpc>
               <a:spcAft>
-                <a:spcPts val="1000"/>
+                <a:spcPts val="1500"/>
               </a:spcAft>
               <a:buClr>
                 <a:srgbClr val="028090"/>
@@ -3537,7 +3498,7 @@
                 </a:solidFill>
                 <a:latin typeface="Calibri"/>
               </a:rPr>
-              <a:t>~200 pruebas automatizadas</a:t>
+              <a:t>Dos estándares: ZipCrypto (débil) y AES-256 (fuerte)</a:t>
             </a:r>
           </a:p>
           <a:p>
@@ -3546,7 +3507,7 @@
                 <a:spcPct val="110000"/>
               </a:lnSpc>
               <a:spcAft>
-                <a:spcPts val="1000"/>
+                <a:spcPts val="1500"/>
               </a:spcAft>
               <a:buClr>
                 <a:srgbClr val="028090"/>
@@ -3561,79 +3522,16 @@
                 </a:solidFill>
                 <a:latin typeface="Calibri"/>
               </a:rPr>
-              <a:t>Integración continua en cada cambio</a:t>
-            </a:r>
-          </a:p>
-        </p:txBody>
-      </p:sp>
-      <p:sp>
-        <p:nvSpPr>
-          <p:cNvPr id="7" name="TextBox 6"/>
-          <p:cNvSpPr txBox="1"/>
-          <p:nvPr/>
-        </p:nvSpPr>
-        <p:spPr>
-          <a:xfrm>
-            <a:off x="1024128" y="3840480"/>
-            <a:ext cx="10058400" cy="457200"/>
-          </a:xfrm>
-          <a:prstGeom prst="rect">
-            <a:avLst/>
-          </a:prstGeom>
-          <a:noFill/>
-        </p:spPr>
-        <p:txBody>
-          <a:bodyPr wrap="square" anchor="t" lIns="0" rIns="0" tIns="0" bIns="0">
-            <a:spAutoFit/>
-          </a:bodyPr>
-          <a:lstStyle/>
-          <a:p>
-            <a:pPr algn="l">
-              <a:spcAft>
-                <a:spcPts val="600"/>
-              </a:spcAft>
-              <a:buNone/>
-            </a:pPr>
-            <a:r>
-              <a:rPr sz="1300" b="1" i="0">
-                <a:solidFill>
-                  <a:srgbClr val="028090"/>
-                </a:solidFill>
-                <a:latin typeface="Calibri"/>
-              </a:rPr>
-              <a:t>SEGURIDAD</a:t>
-            </a:r>
-          </a:p>
-        </p:txBody>
-      </p:sp>
-      <p:sp>
-        <p:nvSpPr>
-          <p:cNvPr id="8" name="TextBox 7"/>
-          <p:cNvSpPr txBox="1"/>
-          <p:nvPr/>
-        </p:nvSpPr>
-        <p:spPr>
-          <a:xfrm>
-            <a:off x="1024128" y="4251960"/>
-            <a:ext cx="10058400" cy="4206240"/>
-          </a:xfrm>
-          <a:prstGeom prst="rect">
-            <a:avLst/>
-          </a:prstGeom>
-          <a:noFill/>
-        </p:spPr>
-        <p:txBody>
-          <a:bodyPr wrap="square" anchor="t" lIns="0" rIns="0" tIns="0" bIns="0">
-            <a:spAutoFit/>
-          </a:bodyPr>
-          <a:lstStyle/>
+              <a:t>Compatible con Finder, WinZip y 7-Zip</a:t>
+            </a:r>
+          </a:p>
           <a:p>
             <a:pPr algn="l" marL="292608" indent="-292608">
               <a:lnSpc>
                 <a:spcPct val="110000"/>
               </a:lnSpc>
               <a:spcAft>
-                <a:spcPts val="1000"/>
+                <a:spcPts val="1500"/>
               </a:spcAft>
               <a:buClr>
                 <a:srgbClr val="028090"/>
@@ -3648,7 +3546,7 @@
                 </a:solidFill>
                 <a:latin typeface="Calibri"/>
               </a:rPr>
-              <a:t>Extracción segura (Zip-Slip) y bombas de descompresión</a:t>
+              <a:t>Lo difícil: encajar el formato byte a byte</a:t>
             </a:r>
           </a:p>
           <a:p>
@@ -3657,7 +3555,7 @@
                 <a:spcPct val="110000"/>
               </a:lnSpc>
               <a:spcAft>
-                <a:spcPts val="1000"/>
+                <a:spcPts val="1500"/>
               </a:spcAft>
               <a:buClr>
                 <a:srgbClr val="028090"/>
@@ -3672,7 +3570,7 @@
                 </a:solidFill>
                 <a:latin typeface="Calibri"/>
               </a:rPr>
-              <a:t>Contraseñas solo en memoria · hardened runtime</a:t>
+              <a:t>Interoperabilidad verificada con pruebas</a:t>
             </a:r>
           </a:p>
         </p:txBody>
@@ -3818,7 +3716,7 @@
                 </a:solidFill>
                 <a:latin typeface="Cambria"/>
               </a:rPr>
-              <a:t>Distribución</a:t>
+              <a:t>Calidad y seguridad</a:t>
             </a:r>
           </a:p>
         </p:txBody>
@@ -3831,7 +3729,47 @@
         </p:nvSpPr>
         <p:spPr>
           <a:xfrm>
-            <a:off x="1024128" y="1920240"/>
+            <a:off x="1024128" y="1874519"/>
+            <a:ext cx="10058400" cy="457200"/>
+          </a:xfrm>
+          <a:prstGeom prst="rect">
+            <a:avLst/>
+          </a:prstGeom>
+          <a:noFill/>
+        </p:spPr>
+        <p:txBody>
+          <a:bodyPr wrap="square" anchor="t" lIns="0" rIns="0" tIns="0" bIns="0">
+            <a:spAutoFit/>
+          </a:bodyPr>
+          <a:lstStyle/>
+          <a:p>
+            <a:pPr algn="l">
+              <a:spcAft>
+                <a:spcPts val="600"/>
+              </a:spcAft>
+              <a:buNone/>
+            </a:pPr>
+            <a:r>
+              <a:rPr sz="1300" b="1" i="0">
+                <a:solidFill>
+                  <a:srgbClr val="028090"/>
+                </a:solidFill>
+                <a:latin typeface="Calibri"/>
+              </a:rPr>
+              <a:t>CALIDAD</a:t>
+            </a:r>
+          </a:p>
+        </p:txBody>
+      </p:sp>
+      <p:sp>
+        <p:nvSpPr>
+          <p:cNvPr id="6" name="TextBox 5"/>
+          <p:cNvSpPr txBox="1"/>
+          <p:nvPr/>
+        </p:nvSpPr>
+        <p:spPr>
+          <a:xfrm>
+            <a:off x="1024128" y="2286000"/>
             <a:ext cx="10058400" cy="4206240"/>
           </a:xfrm>
           <a:prstGeom prst="rect">
@@ -3850,7 +3788,7 @@
                 <a:spcPct val="110000"/>
               </a:lnSpc>
               <a:spcAft>
-                <a:spcPts val="1500"/>
+                <a:spcPts val="1000"/>
               </a:spcAft>
               <a:buClr>
                 <a:srgbClr val="028090"/>
@@ -3865,7 +3803,7 @@
                 </a:solidFill>
                 <a:latin typeface="Calibri"/>
               </a:rPr>
-              <a:t>Empaquetada en .dmg (script reproducible)</a:t>
+              <a:t>244 pruebas automatizadas</a:t>
             </a:r>
           </a:p>
           <a:p>
@@ -3874,7 +3812,7 @@
                 <a:spcPct val="110000"/>
               </a:lnSpc>
               <a:spcAft>
-                <a:spcPts val="1500"/>
+                <a:spcPts val="1000"/>
               </a:spcAft>
               <a:buClr>
                 <a:srgbClr val="028090"/>
@@ -3889,16 +3827,79 @@
                 </a:solidFill>
                 <a:latin typeface="Calibri"/>
               </a:rPr>
-              <a:t>Hardened runtime, lista para notarizar</a:t>
-            </a:r>
-          </a:p>
+              <a:t>Integración continua en cada cambio</a:t>
+            </a:r>
+          </a:p>
+        </p:txBody>
+      </p:sp>
+      <p:sp>
+        <p:nvSpPr>
+          <p:cNvPr id="7" name="TextBox 6"/>
+          <p:cNvSpPr txBox="1"/>
+          <p:nvPr/>
+        </p:nvSpPr>
+        <p:spPr>
+          <a:xfrm>
+            <a:off x="1024128" y="3840480"/>
+            <a:ext cx="10058400" cy="457200"/>
+          </a:xfrm>
+          <a:prstGeom prst="rect">
+            <a:avLst/>
+          </a:prstGeom>
+          <a:noFill/>
+        </p:spPr>
+        <p:txBody>
+          <a:bodyPr wrap="square" anchor="t" lIns="0" rIns="0" tIns="0" bIns="0">
+            <a:spAutoFit/>
+          </a:bodyPr>
+          <a:lstStyle/>
+          <a:p>
+            <a:pPr algn="l">
+              <a:spcAft>
+                <a:spcPts val="600"/>
+              </a:spcAft>
+              <a:buNone/>
+            </a:pPr>
+            <a:r>
+              <a:rPr sz="1300" b="1" i="0">
+                <a:solidFill>
+                  <a:srgbClr val="028090"/>
+                </a:solidFill>
+                <a:latin typeface="Calibri"/>
+              </a:rPr>
+              <a:t>SEGURIDAD</a:t>
+            </a:r>
+          </a:p>
+        </p:txBody>
+      </p:sp>
+      <p:sp>
+        <p:nvSpPr>
+          <p:cNvPr id="8" name="TextBox 7"/>
+          <p:cNvSpPr txBox="1"/>
+          <p:nvPr/>
+        </p:nvSpPr>
+        <p:spPr>
+          <a:xfrm>
+            <a:off x="1024128" y="4251960"/>
+            <a:ext cx="10058400" cy="4206240"/>
+          </a:xfrm>
+          <a:prstGeom prst="rect">
+            <a:avLst/>
+          </a:prstGeom>
+          <a:noFill/>
+        </p:spPr>
+        <p:txBody>
+          <a:bodyPr wrap="square" anchor="t" lIns="0" rIns="0" tIns="0" bIns="0">
+            <a:spAutoFit/>
+          </a:bodyPr>
+          <a:lstStyle/>
           <a:p>
             <a:pPr algn="l" marL="292608" indent="-292608">
               <a:lnSpc>
                 <a:spcPct val="110000"/>
               </a:lnSpc>
               <a:spcAft>
-                <a:spcPts val="1500"/>
+                <a:spcPts val="1000"/>
               </a:spcAft>
               <a:buClr>
                 <a:srgbClr val="028090"/>
@@ -3913,7 +3914,7 @@
                 </a:solidFill>
                 <a:latin typeface="Calibri"/>
               </a:rPr>
-              <a:t>Open source: compilable desde el código</a:t>
+              <a:t>Extracción segura (Zip-Slip) y bombas de descompresión</a:t>
             </a:r>
           </a:p>
           <a:p>
@@ -3922,7 +3923,7 @@
                 <a:spcPct val="110000"/>
               </a:lnSpc>
               <a:spcAft>
-                <a:spcPts val="1500"/>
+                <a:spcPts val="1000"/>
               </a:spcAft>
               <a:buClr>
                 <a:srgbClr val="028090"/>
@@ -3937,7 +3938,7 @@
                 </a:solidFill>
                 <a:latin typeface="Calibri"/>
               </a:rPr>
-              <a:t>Publicada como GitHub Release</a:t>
+              <a:t>Contraseñas solo en memoria · hardened runtime</a:t>
             </a:r>
           </a:p>
         </p:txBody>
@@ -4083,7 +4084,7 @@
                 </a:solidFill>
                 <a:latin typeface="Cambria"/>
               </a:rPr>
-              <a:t>Retos y aprendizajes</a:t>
+              <a:t>Distribución</a:t>
             </a:r>
           </a:p>
         </p:txBody>
@@ -4096,47 +4097,7 @@
         </p:nvSpPr>
         <p:spPr>
           <a:xfrm>
-            <a:off x="1024128" y="1874519"/>
-            <a:ext cx="10058400" cy="457200"/>
-          </a:xfrm>
-          <a:prstGeom prst="rect">
-            <a:avLst/>
-          </a:prstGeom>
-          <a:noFill/>
-        </p:spPr>
-        <p:txBody>
-          <a:bodyPr wrap="square" anchor="t" lIns="0" rIns="0" tIns="0" bIns="0">
-            <a:spAutoFit/>
-          </a:bodyPr>
-          <a:lstStyle/>
-          <a:p>
-            <a:pPr algn="l">
-              <a:spcAft>
-                <a:spcPts val="600"/>
-              </a:spcAft>
-              <a:buNone/>
-            </a:pPr>
-            <a:r>
-              <a:rPr sz="1300" b="1" i="0">
-                <a:solidFill>
-                  <a:srgbClr val="028090"/>
-                </a:solidFill>
-                <a:latin typeface="Calibri"/>
-              </a:rPr>
-              <a:t>RETOS</a:t>
-            </a:r>
-          </a:p>
-        </p:txBody>
-      </p:sp>
-      <p:sp>
-        <p:nvSpPr>
-          <p:cNvPr id="6" name="TextBox 5"/>
-          <p:cNvSpPr txBox="1"/>
-          <p:nvPr/>
-        </p:nvSpPr>
-        <p:spPr>
-          <a:xfrm>
-            <a:off x="1024128" y="2286000"/>
+            <a:off x="1024128" y="1920240"/>
             <a:ext cx="10058400" cy="4206240"/>
           </a:xfrm>
           <a:prstGeom prst="rect">
@@ -4155,7 +4116,7 @@
                 <a:spcPct val="110000"/>
               </a:lnSpc>
               <a:spcAft>
-                <a:spcPts val="1000"/>
+                <a:spcPts val="1500"/>
               </a:spcAft>
               <a:buClr>
                 <a:srgbClr val="028090"/>
@@ -4170,7 +4131,7 @@
                 </a:solidFill>
                 <a:latin typeface="Calibri"/>
               </a:rPr>
-              <a:t>Formatos binarios byte a byte</a:t>
+              <a:t>Empaquetada en .dmg (script reproducible)</a:t>
             </a:r>
           </a:p>
           <a:p>
@@ -4179,7 +4140,7 @@
                 <a:spcPct val="110000"/>
               </a:lnSpc>
               <a:spcAft>
-                <a:spcPts val="1000"/>
+                <a:spcPts val="1500"/>
               </a:spcAft>
               <a:buClr>
                 <a:srgbClr val="028090"/>
@@ -4194,79 +4155,16 @@
                 </a:solidFill>
                 <a:latin typeface="Calibri"/>
               </a:rPr>
-              <a:t>Streaming con acceso aleatorio</a:t>
-            </a:r>
-          </a:p>
-        </p:txBody>
-      </p:sp>
-      <p:sp>
-        <p:nvSpPr>
-          <p:cNvPr id="7" name="TextBox 6"/>
-          <p:cNvSpPr txBox="1"/>
-          <p:nvPr/>
-        </p:nvSpPr>
-        <p:spPr>
-          <a:xfrm>
-            <a:off x="1024128" y="3840480"/>
-            <a:ext cx="10058400" cy="457200"/>
-          </a:xfrm>
-          <a:prstGeom prst="rect">
-            <a:avLst/>
-          </a:prstGeom>
-          <a:noFill/>
-        </p:spPr>
-        <p:txBody>
-          <a:bodyPr wrap="square" anchor="t" lIns="0" rIns="0" tIns="0" bIns="0">
-            <a:spAutoFit/>
-          </a:bodyPr>
-          <a:lstStyle/>
-          <a:p>
-            <a:pPr algn="l">
-              <a:spcAft>
-                <a:spcPts val="600"/>
-              </a:spcAft>
-              <a:buNone/>
-            </a:pPr>
-            <a:r>
-              <a:rPr sz="1300" b="1" i="0">
-                <a:solidFill>
-                  <a:srgbClr val="028090"/>
-                </a:solidFill>
-                <a:latin typeface="Calibri"/>
-              </a:rPr>
-              <a:t>APRENDIZAJES</a:t>
-            </a:r>
-          </a:p>
-        </p:txBody>
-      </p:sp>
-      <p:sp>
-        <p:nvSpPr>
-          <p:cNvPr id="8" name="TextBox 7"/>
-          <p:cNvSpPr txBox="1"/>
-          <p:nvPr/>
-        </p:nvSpPr>
-        <p:spPr>
-          <a:xfrm>
-            <a:off x="1024128" y="4251960"/>
-            <a:ext cx="10058400" cy="4206240"/>
-          </a:xfrm>
-          <a:prstGeom prst="rect">
-            <a:avLst/>
-          </a:prstGeom>
-          <a:noFill/>
-        </p:spPr>
-        <p:txBody>
-          <a:bodyPr wrap="square" anchor="t" lIns="0" rIns="0" tIns="0" bIns="0">
-            <a:spAutoFit/>
-          </a:bodyPr>
-          <a:lstStyle/>
+              <a:t>Hardened runtime, lista para notarizar</a:t>
+            </a:r>
+          </a:p>
           <a:p>
             <a:pPr algn="l" marL="292608" indent="-292608">
               <a:lnSpc>
                 <a:spcPct val="110000"/>
               </a:lnSpc>
               <a:spcAft>
-                <a:spcPts val="1000"/>
+                <a:spcPts val="1500"/>
               </a:spcAft>
               <a:buClr>
                 <a:srgbClr val="028090"/>
@@ -4281,7 +4179,7 @@
                 </a:solidFill>
                 <a:latin typeface="Calibri"/>
               </a:rPr>
-              <a:t>Diseñar para lo desconocido</a:t>
+              <a:t>Open source: compilable desde el código</a:t>
             </a:r>
           </a:p>
           <a:p>
@@ -4290,7 +4188,7 @@
                 <a:spcPct val="110000"/>
               </a:lnSpc>
               <a:spcAft>
-                <a:spcPts val="1000"/>
+                <a:spcPts val="1500"/>
               </a:spcAft>
               <a:buClr>
                 <a:srgbClr val="028090"/>
@@ -4305,7 +4203,7 @@
                 </a:solidFill>
                 <a:latin typeface="Calibri"/>
               </a:rPr>
-              <a:t>Verificar contra el mundo real · separar lógica y UI</a:t>
+              <a:t>Publicada como GitHub Release</a:t>
             </a:r>
           </a:p>
         </p:txBody>
@@ -4451,7 +4349,7 @@
                 </a:solidFill>
                 <a:latin typeface="Cambria"/>
               </a:rPr>
-              <a:t>Futuro</a:t>
+              <a:t>Retos y aprendizajes</a:t>
             </a:r>
           </a:p>
         </p:txBody>
@@ -4464,7 +4362,47 @@
         </p:nvSpPr>
         <p:spPr>
           <a:xfrm>
-            <a:off x="1024128" y="1920240"/>
+            <a:off x="1024128" y="1874519"/>
+            <a:ext cx="10058400" cy="457200"/>
+          </a:xfrm>
+          <a:prstGeom prst="rect">
+            <a:avLst/>
+          </a:prstGeom>
+          <a:noFill/>
+        </p:spPr>
+        <p:txBody>
+          <a:bodyPr wrap="square" anchor="t" lIns="0" rIns="0" tIns="0" bIns="0">
+            <a:spAutoFit/>
+          </a:bodyPr>
+          <a:lstStyle/>
+          <a:p>
+            <a:pPr algn="l">
+              <a:spcAft>
+                <a:spcPts val="600"/>
+              </a:spcAft>
+              <a:buNone/>
+            </a:pPr>
+            <a:r>
+              <a:rPr sz="1300" b="1" i="0">
+                <a:solidFill>
+                  <a:srgbClr val="028090"/>
+                </a:solidFill>
+                <a:latin typeface="Calibri"/>
+              </a:rPr>
+              <a:t>RETOS</a:t>
+            </a:r>
+          </a:p>
+        </p:txBody>
+      </p:sp>
+      <p:sp>
+        <p:nvSpPr>
+          <p:cNvPr id="6" name="TextBox 5"/>
+          <p:cNvSpPr txBox="1"/>
+          <p:nvPr/>
+        </p:nvSpPr>
+        <p:spPr>
+          <a:xfrm>
+            <a:off x="1024128" y="2286000"/>
             <a:ext cx="10058400" cy="4206240"/>
           </a:xfrm>
           <a:prstGeom prst="rect">
@@ -4483,7 +4421,7 @@
                 <a:spcPct val="110000"/>
               </a:lnSpc>
               <a:spcAft>
-                <a:spcPts val="1500"/>
+                <a:spcPts val="1000"/>
               </a:spcAft>
               <a:buClr>
                 <a:srgbClr val="028090"/>
@@ -4498,7 +4436,7 @@
                 </a:solidFill>
                 <a:latin typeface="Calibri"/>
               </a:rPr>
-              <a:t>Cifrado al escribir en más formatos</a:t>
+              <a:t>Formatos binarios byte a byte</a:t>
             </a:r>
           </a:p>
           <a:p>
@@ -4507,7 +4445,7 @@
                 <a:spcPct val="110000"/>
               </a:lnSpc>
               <a:spcAft>
-                <a:spcPts val="1500"/>
+                <a:spcPts val="1000"/>
               </a:spcAft>
               <a:buClr>
                 <a:srgbClr val="028090"/>
@@ -4522,7 +4460,7 @@
                 </a:solidFill>
                 <a:latin typeface="Calibri"/>
               </a:rPr>
-              <a:t>Optimizar el rendimiento del cifrado</a:t>
+              <a:t>Streaming con acceso aleatorio</a:t>
             </a:r>
           </a:p>
           <a:p>
@@ -4531,7 +4469,7 @@
                 <a:spcPct val="110000"/>
               </a:lnSpc>
               <a:spcAft>
-                <a:spcPts val="1500"/>
+                <a:spcPts val="1000"/>
               </a:spcAft>
               <a:buClr>
                 <a:srgbClr val="028090"/>
@@ -4546,16 +4484,79 @@
                 </a:solidFill>
                 <a:latin typeface="Calibri"/>
               </a:rPr>
-              <a:t>Más formatos y motores de compresión</a:t>
-            </a:r>
-          </a:p>
+              <a:t>Archivos incompletos o con esquemas distintos</a:t>
+            </a:r>
+          </a:p>
+        </p:txBody>
+      </p:sp>
+      <p:sp>
+        <p:nvSpPr>
+          <p:cNvPr id="7" name="TextBox 6"/>
+          <p:cNvSpPr txBox="1"/>
+          <p:nvPr/>
+        </p:nvSpPr>
+        <p:spPr>
+          <a:xfrm>
+            <a:off x="1024128" y="3840480"/>
+            <a:ext cx="10058400" cy="457200"/>
+          </a:xfrm>
+          <a:prstGeom prst="rect">
+            <a:avLst/>
+          </a:prstGeom>
+          <a:noFill/>
+        </p:spPr>
+        <p:txBody>
+          <a:bodyPr wrap="square" anchor="t" lIns="0" rIns="0" tIns="0" bIns="0">
+            <a:spAutoFit/>
+          </a:bodyPr>
+          <a:lstStyle/>
+          <a:p>
+            <a:pPr algn="l">
+              <a:spcAft>
+                <a:spcPts val="600"/>
+              </a:spcAft>
+              <a:buNone/>
+            </a:pPr>
+            <a:r>
+              <a:rPr sz="1300" b="1" i="0">
+                <a:solidFill>
+                  <a:srgbClr val="028090"/>
+                </a:solidFill>
+                <a:latin typeface="Calibri"/>
+              </a:rPr>
+              <a:t>APRENDIZAJES</a:t>
+            </a:r>
+          </a:p>
+        </p:txBody>
+      </p:sp>
+      <p:sp>
+        <p:nvSpPr>
+          <p:cNvPr id="8" name="TextBox 7"/>
+          <p:cNvSpPr txBox="1"/>
+          <p:nvPr/>
+        </p:nvSpPr>
+        <p:spPr>
+          <a:xfrm>
+            <a:off x="1024128" y="4251960"/>
+            <a:ext cx="10058400" cy="4206240"/>
+          </a:xfrm>
+          <a:prstGeom prst="rect">
+            <a:avLst/>
+          </a:prstGeom>
+          <a:noFill/>
+        </p:spPr>
+        <p:txBody>
+          <a:bodyPr wrap="square" anchor="t" lIns="0" rIns="0" tIns="0" bIns="0">
+            <a:spAutoFit/>
+          </a:bodyPr>
+          <a:lstStyle/>
           <a:p>
             <a:pPr algn="l" marL="292608" indent="-292608">
               <a:lnSpc>
                 <a:spcPct val="110000"/>
               </a:lnSpc>
               <a:spcAft>
-                <a:spcPts val="1500"/>
+                <a:spcPts val="1000"/>
               </a:spcAft>
               <a:buClr>
                 <a:srgbClr val="028090"/>
@@ -4570,7 +4571,31 @@
                 </a:solidFill>
                 <a:latin typeface="Calibri"/>
               </a:rPr>
-              <a:t>Notarización: distribución sin fricción</a:t>
+              <a:t>Diseñar para lo desconocido</a:t>
+            </a:r>
+          </a:p>
+          <a:p>
+            <a:pPr algn="l" marL="292608" indent="-292608">
+              <a:lnSpc>
+                <a:spcPct val="110000"/>
+              </a:lnSpc>
+              <a:spcAft>
+                <a:spcPts val="1000"/>
+              </a:spcAft>
+              <a:buClr>
+                <a:srgbClr val="028090"/>
+              </a:buClr>
+              <a:buFont typeface="Arial"/>
+              <a:buChar char="—"/>
+            </a:pPr>
+            <a:r>
+              <a:rPr sz="1800" b="0" i="0">
+                <a:solidFill>
+                  <a:srgbClr val="1E2C33"/>
+                </a:solidFill>
+                <a:latin typeface="Calibri"/>
+              </a:rPr>
+              <a:t>Verificar contra el mundo real · separar lógica y UI</a:t>
             </a:r>
           </a:p>
         </p:txBody>
@@ -4608,6 +4633,271 @@
             <a:avLst/>
           </a:prstGeom>
           <a:solidFill>
+            <a:srgbClr val="FFFFFF"/>
+          </a:solidFill>
+          <a:ln>
+            <a:noFill/>
+          </a:ln>
+          <a:effectLst/>
+        </p:spPr>
+        <p:style>
+          <a:lnRef idx="1">
+            <a:schemeClr val="accent1"/>
+          </a:lnRef>
+          <a:fillRef idx="3">
+            <a:schemeClr val="accent1"/>
+          </a:fillRef>
+          <a:effectRef idx="2">
+            <a:schemeClr val="accent1"/>
+          </a:effectRef>
+          <a:fontRef idx="minor">
+            <a:schemeClr val="lt1"/>
+          </a:fontRef>
+        </p:style>
+        <p:txBody>
+          <a:bodyPr rtlCol="0" anchor="ctr"/>
+          <a:lstStyle/>
+          <a:p>
+            <a:pPr algn="ctr"/>
+          </a:p>
+        </p:txBody>
+      </p:sp>
+      <p:sp>
+        <p:nvSpPr>
+          <p:cNvPr id="3" name="Rectangle 2"/>
+          <p:cNvSpPr/>
+          <p:nvPr/>
+        </p:nvSpPr>
+        <p:spPr>
+          <a:xfrm>
+            <a:off x="731520" y="749808"/>
+            <a:ext cx="146304" cy="146304"/>
+          </a:xfrm>
+          <a:prstGeom prst="rect">
+            <a:avLst/>
+          </a:prstGeom>
+          <a:solidFill>
+            <a:srgbClr val="02C39A"/>
+          </a:solidFill>
+          <a:ln>
+            <a:noFill/>
+          </a:ln>
+          <a:effectLst/>
+        </p:spPr>
+        <p:style>
+          <a:lnRef idx="1">
+            <a:schemeClr val="accent1"/>
+          </a:lnRef>
+          <a:fillRef idx="3">
+            <a:schemeClr val="accent1"/>
+          </a:fillRef>
+          <a:effectRef idx="2">
+            <a:schemeClr val="accent1"/>
+          </a:effectRef>
+          <a:fontRef idx="minor">
+            <a:schemeClr val="lt1"/>
+          </a:fontRef>
+        </p:style>
+        <p:txBody>
+          <a:bodyPr rtlCol="0" anchor="ctr"/>
+          <a:lstStyle/>
+          <a:p>
+            <a:pPr algn="ctr"/>
+          </a:p>
+        </p:txBody>
+      </p:sp>
+      <p:sp>
+        <p:nvSpPr>
+          <p:cNvPr id="4" name="TextBox 3"/>
+          <p:cNvSpPr txBox="1"/>
+          <p:nvPr/>
+        </p:nvSpPr>
+        <p:spPr>
+          <a:xfrm>
+            <a:off x="1024128" y="603504"/>
+            <a:ext cx="10241280" cy="822960"/>
+          </a:xfrm>
+          <a:prstGeom prst="rect">
+            <a:avLst/>
+          </a:prstGeom>
+          <a:noFill/>
+        </p:spPr>
+        <p:txBody>
+          <a:bodyPr wrap="square" anchor="t" lIns="0" rIns="0" tIns="0" bIns="0">
+            <a:spAutoFit/>
+          </a:bodyPr>
+          <a:lstStyle/>
+          <a:p>
+            <a:pPr algn="l">
+              <a:spcAft>
+                <a:spcPts val="600"/>
+              </a:spcAft>
+              <a:buNone/>
+            </a:pPr>
+            <a:r>
+              <a:rPr sz="3000" b="1" i="0">
+                <a:solidFill>
+                  <a:srgbClr val="1E2C33"/>
+                </a:solidFill>
+                <a:latin typeface="Cambria"/>
+              </a:rPr>
+              <a:t>Futuro</a:t>
+            </a:r>
+          </a:p>
+        </p:txBody>
+      </p:sp>
+      <p:sp>
+        <p:nvSpPr>
+          <p:cNvPr id="5" name="TextBox 4"/>
+          <p:cNvSpPr txBox="1"/>
+          <p:nvPr/>
+        </p:nvSpPr>
+        <p:spPr>
+          <a:xfrm>
+            <a:off x="1024128" y="1920240"/>
+            <a:ext cx="10058400" cy="4206240"/>
+          </a:xfrm>
+          <a:prstGeom prst="rect">
+            <a:avLst/>
+          </a:prstGeom>
+          <a:noFill/>
+        </p:spPr>
+        <p:txBody>
+          <a:bodyPr wrap="square" anchor="t" lIns="0" rIns="0" tIns="0" bIns="0">
+            <a:spAutoFit/>
+          </a:bodyPr>
+          <a:lstStyle/>
+          <a:p>
+            <a:pPr algn="l" marL="292608" indent="-292608">
+              <a:lnSpc>
+                <a:spcPct val="110000"/>
+              </a:lnSpc>
+              <a:spcAft>
+                <a:spcPts val="1500"/>
+              </a:spcAft>
+              <a:buClr>
+                <a:srgbClr val="028090"/>
+              </a:buClr>
+              <a:buFont typeface="Arial"/>
+              <a:buChar char="—"/>
+            </a:pPr>
+            <a:r>
+              <a:rPr sz="1800" b="0" i="0">
+                <a:solidFill>
+                  <a:srgbClr val="1E2C33"/>
+                </a:solidFill>
+                <a:latin typeface="Calibri"/>
+              </a:rPr>
+              <a:t>Cifrado al escribir en más formatos</a:t>
+            </a:r>
+          </a:p>
+          <a:p>
+            <a:pPr algn="l" marL="292608" indent="-292608">
+              <a:lnSpc>
+                <a:spcPct val="110000"/>
+              </a:lnSpc>
+              <a:spcAft>
+                <a:spcPts val="1500"/>
+              </a:spcAft>
+              <a:buClr>
+                <a:srgbClr val="028090"/>
+              </a:buClr>
+              <a:buFont typeface="Arial"/>
+              <a:buChar char="—"/>
+            </a:pPr>
+            <a:r>
+              <a:rPr sz="1800" b="0" i="0">
+                <a:solidFill>
+                  <a:srgbClr val="1E2C33"/>
+                </a:solidFill>
+                <a:latin typeface="Calibri"/>
+              </a:rPr>
+              <a:t>Optimizar el rendimiento del cifrado</a:t>
+            </a:r>
+          </a:p>
+          <a:p>
+            <a:pPr algn="l" marL="292608" indent="-292608">
+              <a:lnSpc>
+                <a:spcPct val="110000"/>
+              </a:lnSpc>
+              <a:spcAft>
+                <a:spcPts val="1500"/>
+              </a:spcAft>
+              <a:buClr>
+                <a:srgbClr val="028090"/>
+              </a:buClr>
+              <a:buFont typeface="Arial"/>
+              <a:buChar char="—"/>
+            </a:pPr>
+            <a:r>
+              <a:rPr sz="1800" b="0" i="0">
+                <a:solidFill>
+                  <a:srgbClr val="1E2C33"/>
+                </a:solidFill>
+                <a:latin typeface="Calibri"/>
+              </a:rPr>
+              <a:t>Más formatos y motores de compresión</a:t>
+            </a:r>
+          </a:p>
+          <a:p>
+            <a:pPr algn="l" marL="292608" indent="-292608">
+              <a:lnSpc>
+                <a:spcPct val="110000"/>
+              </a:lnSpc>
+              <a:spcAft>
+                <a:spcPts val="1500"/>
+              </a:spcAft>
+              <a:buClr>
+                <a:srgbClr val="028090"/>
+              </a:buClr>
+              <a:buFont typeface="Arial"/>
+              <a:buChar char="—"/>
+            </a:pPr>
+            <a:r>
+              <a:rPr sz="1800" b="0" i="0">
+                <a:solidFill>
+                  <a:srgbClr val="1E2C33"/>
+                </a:solidFill>
+                <a:latin typeface="Calibri"/>
+              </a:rPr>
+              <a:t>Notarización: distribución sin fricción</a:t>
+            </a:r>
+          </a:p>
+        </p:txBody>
+      </p:sp>
+    </p:spTree>
+  </p:cSld>
+  <p:clrMapOvr>
+    <a:masterClrMapping/>
+  </p:clrMapOvr>
+</p:sld>
+</file>
+
+<file path=ppt/slides/slide15.xml><?xml version="1.0" encoding="utf-8"?>
+<p:sld xmlns:a="http://schemas.openxmlformats.org/drawingml/2006/main" xmlns:p="http://schemas.openxmlformats.org/presentationml/2006/main" xmlns:r="http://schemas.openxmlformats.org/officeDocument/2006/relationships">
+  <p:cSld>
+    <p:spTree>
+      <p:nvGrpSpPr>
+        <p:cNvPr id="1" name=""/>
+        <p:cNvGrpSpPr/>
+        <p:nvPr/>
+      </p:nvGrpSpPr>
+      <p:grpSpPr/>
+      <p:sp>
+        <p:nvSpPr>
+          <p:cNvPr id="2" name="Rectangle 1"/>
+          <p:cNvSpPr/>
+          <p:nvPr/>
+        </p:nvSpPr>
+        <p:spPr>
+          <a:xfrm>
+            <a:off x="0" y="0"/>
+            <a:ext cx="12191695" cy="6858000"/>
+          </a:xfrm>
+          <a:prstGeom prst="rect">
+            <a:avLst/>
+          </a:prstGeom>
+          <a:solidFill>
             <a:srgbClr val="0F2933"/>
           </a:solidFill>
           <a:ln>
@@ -5033,6 +5323,30 @@
               <a:t>Cada formato, una herramienta distinta</a:t>
             </a:r>
           </a:p>
+          <a:p>
+            <a:pPr algn="l" marL="292608" indent="-292608">
+              <a:lnSpc>
+                <a:spcPct val="110000"/>
+              </a:lnSpc>
+              <a:spcAft>
+                <a:spcPts val="1000"/>
+              </a:spcAft>
+              <a:buClr>
+                <a:srgbClr val="028090"/>
+              </a:buClr>
+              <a:buFont typeface="Arial"/>
+              <a:buChar char="—"/>
+            </a:pPr>
+            <a:r>
+              <a:rPr sz="1800" b="0" i="0">
+                <a:solidFill>
+                  <a:srgbClr val="1E2C33"/>
+                </a:solidFill>
+                <a:latin typeface="Calibri"/>
+              </a:rPr>
+              <a:t>Una misma app para comprimir y descomprimir</a:t>
+            </a:r>
+          </a:p>
         </p:txBody>
       </p:sp>
       <p:sp>
@@ -5454,6 +5768,30 @@
                 </a:solidFill>
                 <a:latin typeface="Calibri"/>
               </a:rPr>
+              <a:t>Volúmenes RAR nativos</a:t>
+            </a:r>
+          </a:p>
+          <a:p>
+            <a:pPr algn="l" marL="292608" indent="-292608">
+              <a:lnSpc>
+                <a:spcPct val="110000"/>
+              </a:lnSpc>
+              <a:spcAft>
+                <a:spcPts val="1300"/>
+              </a:spcAft>
+              <a:buClr>
+                <a:srgbClr val="028090"/>
+              </a:buClr>
+              <a:buFont typeface="Arial"/>
+              <a:buChar char="—"/>
+            </a:pPr>
+            <a:r>
+              <a:rPr sz="1900" b="0" i="0">
+                <a:solidFill>
+                  <a:srgbClr val="1E2C33"/>
+                </a:solidFill>
+                <a:latin typeface="Calibri"/>
+              </a:rPr>
               <a:t>Cifrar al exportar</a:t>
             </a:r>
           </a:p>
@@ -6560,7 +6898,7 @@
                 </a:solidFill>
                 <a:latin typeface="Cambria"/>
               </a:rPr>
-              <a:t>Decisión: abstracción por formato</a:t>
+              <a:t>Librerías externas</a:t>
             </a:r>
           </a:p>
         </p:txBody>
@@ -6600,7 +6938,7 @@
                 </a:solidFill>
                 <a:latin typeface="Courier New"/>
               </a:rPr>
-              <a:t>ArchiveFormat   </a:t>
+              <a:t>libarchive   </a:t>
             </a:r>
             <a:r>
               <a:rPr sz="1700" b="0" i="0">
@@ -6609,7 +6947,7 @@
                 </a:solidFill>
                 <a:latin typeface="Calibri"/>
               </a:rPr>
-              <a:t>capacidades + detección del formato</a:t>
+              <a:t>7z, rar, iso, cpio, xar, lha, cab</a:t>
             </a:r>
           </a:p>
         </p:txBody>
@@ -6622,7 +6960,7 @@
         </p:nvSpPr>
         <p:spPr>
           <a:xfrm>
-            <a:off x="1024128" y="2788920"/>
+            <a:off x="1024128" y="2763040"/>
             <a:ext cx="10058400" cy="640080"/>
           </a:xfrm>
           <a:prstGeom prst="rect">
@@ -6649,7 +6987,7 @@
                 </a:solidFill>
                 <a:latin typeface="Courier New"/>
               </a:rPr>
-              <a:t>ArchiveCodec   </a:t>
+              <a:t>zlib / liblzma   </a:t>
             </a:r>
             <a:r>
               <a:rPr sz="1700" b="0" i="0">
@@ -6658,7 +6996,7 @@
                 </a:solidFill>
                 <a:latin typeface="Calibri"/>
               </a:rPr>
-              <a:t>interfaz común: leer y extraer</a:t>
+              <a:t>comprimir al escribir (nivel elegible)</a:t>
             </a:r>
           </a:p>
         </p:txBody>
@@ -6671,7 +7009,7 @@
         </p:nvSpPr>
         <p:spPr>
           <a:xfrm>
-            <a:off x="1024128" y="3611880"/>
+            <a:off x="1024128" y="3560120"/>
             <a:ext cx="10058400" cy="640080"/>
           </a:xfrm>
           <a:prstGeom prst="rect">
@@ -6698,7 +7036,7 @@
                 </a:solidFill>
                 <a:latin typeface="Courier New"/>
               </a:rPr>
-              <a:t>ArchiveEntry   </a:t>
+              <a:t>Compression (Apple)   </a:t>
             </a:r>
             <a:r>
               <a:rPr sz="1700" b="0" i="0">
@@ -6707,7 +7045,7 @@
                 </a:solidFill>
                 <a:latin typeface="Calibri"/>
               </a:rPr>
-              <a:t>entrada neutral, igual para todos</a:t>
+              <a:t>descomprimir al leer (sin nivel)</a:t>
             </a:r>
           </a:p>
         </p:txBody>
@@ -6720,7 +7058,7 @@
         </p:nvSpPr>
         <p:spPr>
           <a:xfrm>
-            <a:off x="1024128" y="4937760"/>
+            <a:off x="1024128" y="5951360"/>
             <a:ext cx="10058400" cy="548640"/>
           </a:xfrm>
           <a:prstGeom prst="rect">
@@ -6747,7 +7085,105 @@
                 </a:solidFill>
                 <a:latin typeface="Calibri"/>
               </a:rPr>
-              <a:t>Añadir un formato nuevo = un caso + su codec + su detección</a:t>
+              <a:t>ZIP y tar: 100 % Swift propio — libarchive solo para lo menos frecuente</a:t>
+            </a:r>
+          </a:p>
+        </p:txBody>
+      </p:sp>
+      <p:sp>
+        <p:nvSpPr>
+          <p:cNvPr id="7" name="TextBox 8"/>
+          <p:cNvSpPr txBox="1"/>
+          <p:nvPr/>
+        </p:nvSpPr>
+        <p:spPr>
+          <a:xfrm>
+            <a:off x="1024128" y="4357200"/>
+            <a:ext cx="10058400" cy="640080"/>
+          </a:xfrm>
+          <a:prstGeom prst="rect">
+            <a:avLst/>
+          </a:prstGeom>
+          <a:noFill/>
+        </p:spPr>
+        <p:txBody>
+          <a:bodyPr wrap="square" anchor="t" lIns="0" rIns="0" tIns="0" bIns="0">
+            <a:spAutoFit/>
+          </a:bodyPr>
+          <a:lstStyle/>
+          <a:p>
+            <a:pPr algn="l">
+              <a:spcAft>
+                <a:spcPts val="600"/>
+              </a:spcAft>
+              <a:buNone/>
+            </a:pPr>
+            <a:r>
+              <a:rPr sz="1900" b="1" i="0">
+                <a:solidFill>
+                  <a:srgbClr val="028090"/>
+                </a:solidFill>
+                <a:latin typeface="Courier New"/>
+              </a:rPr>
+              <a:t>libbz2   </a:t>
+            </a:r>
+            <a:r>
+              <a:rPr sz="1700" b="0" i="0">
+                <a:solidFill>
+                  <a:srgbClr val="1E2C33"/>
+                </a:solidFill>
+                <a:latin typeface="Calibri"/>
+              </a:rPr>
+              <a:t>bzip2 completo — lectura y escritura</a:t>
+            </a:r>
+          </a:p>
+        </p:txBody>
+      </p:sp>
+      <p:sp>
+        <p:nvSpPr>
+          <p:cNvPr id="7" name="TextBox 9"/>
+          <p:cNvSpPr txBox="1"/>
+          <p:nvPr/>
+        </p:nvSpPr>
+        <p:spPr>
+          <a:xfrm>
+            <a:off x="1024128" y="5154280"/>
+            <a:ext cx="10058400" cy="640080"/>
+          </a:xfrm>
+          <a:prstGeom prst="rect">
+            <a:avLst/>
+          </a:prstGeom>
+          <a:noFill/>
+        </p:spPr>
+        <p:txBody>
+          <a:bodyPr wrap="square" anchor="t" lIns="0" rIns="0" tIns="0" bIns="0">
+            <a:spAutoFit/>
+          </a:bodyPr>
+          <a:lstStyle/>
+          <a:p>
+            <a:pPr algn="l">
+              <a:spcAft>
+                <a:spcPts val="600"/>
+              </a:spcAft>
+              <a:buNone/>
+            </a:pPr>
+            <a:r>
+              <a:rPr sz="1900" b="1" i="0">
+                <a:solidFill>
+                  <a:srgbClr val="028090"/>
+                </a:solidFill>
+                <a:latin typeface="Courier New"/>
+              </a:rPr>
+              <a:t>CommonCrypto / CryptoKit   </a:t>
+            </a:r>
+            <a:r>
+              <a:rPr sz="1700" b="0" i="0">
+                <a:solidFill>
+                  <a:srgbClr val="1E2C33"/>
+                </a:solidFill>
+                <a:latin typeface="Calibri"/>
+              </a:rPr>
+              <a:t>AES-256 del cifrado ZIP</a:t>
             </a:r>
           </a:p>
         </p:txBody>
@@ -6893,7 +7329,7 @@
                 </a:solidFill>
                 <a:latin typeface="Cambria"/>
               </a:rPr>
-              <a:t>Decisión: memoria constante</a:t>
+              <a:t>Decisión: abstracción por formato</a:t>
             </a:r>
           </a:p>
         </p:txBody>
@@ -6906,8 +7342,8 @@
         </p:nvSpPr>
         <p:spPr>
           <a:xfrm>
-            <a:off x="1024128" y="1920240"/>
-            <a:ext cx="10058400" cy="4206240"/>
+            <a:off x="1024128" y="1965960"/>
+            <a:ext cx="10058400" cy="640080"/>
           </a:xfrm>
           <a:prstGeom prst="rect">
             <a:avLst/>
@@ -6920,75 +7356,167 @@
           </a:bodyPr>
           <a:lstStyle/>
           <a:p>
-            <a:pPr algn="l" marL="292608" indent="-292608">
-              <a:lnSpc>
-                <a:spcPct val="110000"/>
-              </a:lnSpc>
-              <a:spcAft>
-                <a:spcPts val="1600"/>
-              </a:spcAft>
-              <a:buClr>
-                <a:srgbClr val="028090"/>
-              </a:buClr>
-              <a:buFont typeface="Arial"/>
-              <a:buChar char="—"/>
-            </a:pPr>
-            <a:r>
-              <a:rPr sz="1900" b="0" i="0">
+            <a:pPr algn="l">
+              <a:spcAft>
+                <a:spcPts val="600"/>
+              </a:spcAft>
+              <a:buNone/>
+            </a:pPr>
+            <a:r>
+              <a:rPr sz="1900" b="1" i="0">
+                <a:solidFill>
+                  <a:srgbClr val="028090"/>
+                </a:solidFill>
+                <a:latin typeface="Courier New"/>
+              </a:rPr>
+              <a:t>ArchiveFormat   </a:t>
+            </a:r>
+            <a:r>
+              <a:rPr sz="1700" b="0" i="0">
                 <a:solidFill>
                   <a:srgbClr val="1E2C33"/>
                 </a:solidFill>
                 <a:latin typeface="Calibri"/>
               </a:rPr>
-              <a:t>Nunca cargar el archivo entero en RAM</a:t>
-            </a:r>
-          </a:p>
-          <a:p>
-            <a:pPr algn="l" marL="292608" indent="-292608">
-              <a:lnSpc>
-                <a:spcPct val="110000"/>
-              </a:lnSpc>
-              <a:spcAft>
-                <a:spcPts val="1600"/>
-              </a:spcAft>
-              <a:buClr>
-                <a:srgbClr val="028090"/>
-              </a:buClr>
-              <a:buFont typeface="Arial"/>
-              <a:buChar char="—"/>
-            </a:pPr>
-            <a:r>
-              <a:rPr sz="1900" b="0" i="0">
+              <a:t>capacidades + detección del formato</a:t>
+            </a:r>
+          </a:p>
+        </p:txBody>
+      </p:sp>
+      <p:sp>
+        <p:nvSpPr>
+          <p:cNvPr id="6" name="TextBox 5"/>
+          <p:cNvSpPr txBox="1"/>
+          <p:nvPr/>
+        </p:nvSpPr>
+        <p:spPr>
+          <a:xfrm>
+            <a:off x="1024128" y="2788920"/>
+            <a:ext cx="10058400" cy="640080"/>
+          </a:xfrm>
+          <a:prstGeom prst="rect">
+            <a:avLst/>
+          </a:prstGeom>
+          <a:noFill/>
+        </p:spPr>
+        <p:txBody>
+          <a:bodyPr wrap="square" anchor="t" lIns="0" rIns="0" tIns="0" bIns="0">
+            <a:spAutoFit/>
+          </a:bodyPr>
+          <a:lstStyle/>
+          <a:p>
+            <a:pPr algn="l">
+              <a:spcAft>
+                <a:spcPts val="600"/>
+              </a:spcAft>
+              <a:buNone/>
+            </a:pPr>
+            <a:r>
+              <a:rPr sz="1900" b="1" i="0">
+                <a:solidFill>
+                  <a:srgbClr val="028090"/>
+                </a:solidFill>
+                <a:latin typeface="Courier New"/>
+              </a:rPr>
+              <a:t>ArchiveCodec   </a:t>
+            </a:r>
+            <a:r>
+              <a:rPr sz="1700" b="0" i="0">
                 <a:solidFill>
                   <a:srgbClr val="1E2C33"/>
                 </a:solidFill>
                 <a:latin typeface="Calibri"/>
               </a:rPr>
-              <a:t>Streaming: leer → procesar → escribir, por trozos</a:t>
-            </a:r>
-          </a:p>
-          <a:p>
-            <a:pPr algn="l" marL="292608" indent="-292608">
-              <a:lnSpc>
-                <a:spcPct val="110000"/>
-              </a:lnSpc>
-              <a:spcAft>
-                <a:spcPts val="1600"/>
-              </a:spcAft>
-              <a:buClr>
-                <a:srgbClr val="028090"/>
-              </a:buClr>
-              <a:buFont typeface="Arial"/>
-              <a:buChar char="—"/>
-            </a:pPr>
-            <a:r>
-              <a:rPr sz="1900" b="0" i="0">
+              <a:t>interfaz común: leer y extraer</a:t>
+            </a:r>
+          </a:p>
+        </p:txBody>
+      </p:sp>
+      <p:sp>
+        <p:nvSpPr>
+          <p:cNvPr id="7" name="TextBox 6"/>
+          <p:cNvSpPr txBox="1"/>
+          <p:nvPr/>
+        </p:nvSpPr>
+        <p:spPr>
+          <a:xfrm>
+            <a:off x="1024128" y="3611880"/>
+            <a:ext cx="10058400" cy="640080"/>
+          </a:xfrm>
+          <a:prstGeom prst="rect">
+            <a:avLst/>
+          </a:prstGeom>
+          <a:noFill/>
+        </p:spPr>
+        <p:txBody>
+          <a:bodyPr wrap="square" anchor="t" lIns="0" rIns="0" tIns="0" bIns="0">
+            <a:spAutoFit/>
+          </a:bodyPr>
+          <a:lstStyle/>
+          <a:p>
+            <a:pPr algn="l">
+              <a:spcAft>
+                <a:spcPts val="600"/>
+              </a:spcAft>
+              <a:buNone/>
+            </a:pPr>
+            <a:r>
+              <a:rPr sz="1900" b="1" i="0">
+                <a:solidFill>
+                  <a:srgbClr val="028090"/>
+                </a:solidFill>
+                <a:latin typeface="Courier New"/>
+              </a:rPr>
+              <a:t>ArchiveEntry   </a:t>
+            </a:r>
+            <a:r>
+              <a:rPr sz="1700" b="0" i="0">
                 <a:solidFill>
                   <a:srgbClr val="1E2C33"/>
                 </a:solidFill>
                 <a:latin typeface="Calibri"/>
               </a:rPr>
-              <a:t>La RAM no depende del tamaño (10 MB o 10 GB, igual)</a:t>
+              <a:t>entrada neutral, igual para todos</a:t>
+            </a:r>
+          </a:p>
+        </p:txBody>
+      </p:sp>
+      <p:sp>
+        <p:nvSpPr>
+          <p:cNvPr id="8" name="TextBox 7"/>
+          <p:cNvSpPr txBox="1"/>
+          <p:nvPr/>
+        </p:nvSpPr>
+        <p:spPr>
+          <a:xfrm>
+            <a:off x="1024128" y="4937760"/>
+            <a:ext cx="10058400" cy="548640"/>
+          </a:xfrm>
+          <a:prstGeom prst="rect">
+            <a:avLst/>
+          </a:prstGeom>
+          <a:noFill/>
+        </p:spPr>
+        <p:txBody>
+          <a:bodyPr wrap="square" anchor="t" lIns="0" rIns="0" tIns="0" bIns="0">
+            <a:spAutoFit/>
+          </a:bodyPr>
+          <a:lstStyle/>
+          <a:p>
+            <a:pPr algn="l">
+              <a:spcAft>
+                <a:spcPts val="600"/>
+              </a:spcAft>
+              <a:buNone/>
+            </a:pPr>
+            <a:r>
+              <a:rPr sz="1600" b="0" i="1">
+                <a:solidFill>
+                  <a:srgbClr val="607179"/>
+                </a:solidFill>
+                <a:latin typeface="Calibri"/>
+              </a:rPr>
+              <a:t>Añadir un formato nuevo = un caso + su codec + su detección</a:t>
             </a:r>
           </a:p>
         </p:txBody>
@@ -7134,7 +7662,7 @@
                 </a:solidFill>
                 <a:latin typeface="Cambria"/>
               </a:rPr>
-              <a:t>Decisión: cifrado interoperable</a:t>
+              <a:t>Decisión: memoria constante</a:t>
             </a:r>
           </a:p>
         </p:txBody>
@@ -7166,7 +7694,7 @@
                 <a:spcPct val="110000"/>
               </a:lnSpc>
               <a:spcAft>
-                <a:spcPts val="1500"/>
+                <a:spcPts val="1600"/>
               </a:spcAft>
               <a:buClr>
                 <a:srgbClr val="028090"/>
@@ -7175,13 +7703,13 @@
               <a:buChar char="—"/>
             </a:pPr>
             <a:r>
-              <a:rPr sz="1800" b="0" i="0">
+              <a:rPr sz="1900" b="0" i="0">
                 <a:solidFill>
                   <a:srgbClr val="1E2C33"/>
                 </a:solidFill>
                 <a:latin typeface="Calibri"/>
               </a:rPr>
-              <a:t>Dos estándares: ZipCrypto (débil) y AES-256 (fuerte)</a:t>
+              <a:t>Nunca cargar el archivo entero en RAM</a:t>
             </a:r>
           </a:p>
           <a:p>
@@ -7190,7 +7718,7 @@
                 <a:spcPct val="110000"/>
               </a:lnSpc>
               <a:spcAft>
-                <a:spcPts val="1500"/>
+                <a:spcPts val="1600"/>
               </a:spcAft>
               <a:buClr>
                 <a:srgbClr val="028090"/>
@@ -7199,13 +7727,13 @@
               <a:buChar char="—"/>
             </a:pPr>
             <a:r>
-              <a:rPr sz="1800" b="0" i="0">
+              <a:rPr sz="1900" b="0" i="0">
                 <a:solidFill>
                   <a:srgbClr val="1E2C33"/>
                 </a:solidFill>
                 <a:latin typeface="Calibri"/>
               </a:rPr>
-              <a:t>Compatible con Finder, WinZip y 7-Zip</a:t>
+              <a:t>Streaming: leer → procesar → escribir, por trozos</a:t>
             </a:r>
           </a:p>
           <a:p>
@@ -7214,7 +7742,7 @@
                 <a:spcPct val="110000"/>
               </a:lnSpc>
               <a:spcAft>
-                <a:spcPts val="1500"/>
+                <a:spcPts val="1600"/>
               </a:spcAft>
               <a:buClr>
                 <a:srgbClr val="028090"/>
@@ -7223,13 +7751,13 @@
               <a:buChar char="—"/>
             </a:pPr>
             <a:r>
-              <a:rPr sz="1800" b="0" i="0">
+              <a:rPr sz="1900" b="0" i="0">
                 <a:solidFill>
                   <a:srgbClr val="1E2C33"/>
                 </a:solidFill>
                 <a:latin typeface="Calibri"/>
               </a:rPr>
-              <a:t>Lo difícil: encajar el formato byte a byte</a:t>
+              <a:t>La RAM no depende del tamaño (10 MB o 10 GB, igual)</a:t>
             </a:r>
           </a:p>
           <a:p>
@@ -7238,7 +7766,7 @@
                 <a:spcPct val="110000"/>
               </a:lnSpc>
               <a:spcAft>
-                <a:spcPts val="1500"/>
+                <a:spcPts val="1600"/>
               </a:spcAft>
               <a:buClr>
                 <a:srgbClr val="028090"/>
@@ -7247,13 +7775,13 @@
               <a:buChar char="—"/>
             </a:pPr>
             <a:r>
-              <a:rPr sz="1800" b="0" i="0">
+              <a:rPr sz="1900" b="0" i="0">
                 <a:solidFill>
                   <a:srgbClr val="1E2C33"/>
                 </a:solidFill>
                 <a:latin typeface="Calibri"/>
               </a:rPr>
-              <a:t>Interoperabilidad verificada con pruebas</a:t>
+              <a:t>Extracción por lotes: 155× más rápido (7z)</a:t>
             </a:r>
           </a:p>
         </p:txBody>

</xml_diff>